<commit_message>
Make presentation background photos more visible
Lighter blur (was ~28px, now ~13px) and a more transparent scrim (was
~24%, now ~40%) so each slide's photo reads clearly instead of nearly
dissolving into the background tint.
</commit_message>
<xml_diff>
--- a/docs/presentations/FYPro-Presentation.pptx
+++ b/docs/presentations/FYPro-Presentation.pptx
@@ -1716,7 +1716,7 @@
           </a:prstGeom>
           <a:solidFill>
             <a:srgbClr val="F0F4F8">
-              <a:alpha val="76000"/>
+              <a:alpha val="58000"/>
             </a:srgbClr>
           </a:solidFill>
           <a:ln/>
@@ -2104,7 +2104,7 @@
           </a:prstGeom>
           <a:solidFill>
             <a:srgbClr val="F0F4F8">
-              <a:alpha val="76000"/>
+              <a:alpha val="58000"/>
             </a:srgbClr>
           </a:solidFill>
           <a:ln/>
@@ -2603,7 +2603,7 @@
           </a:prstGeom>
           <a:solidFill>
             <a:srgbClr val="F0F4F8">
-              <a:alpha val="76000"/>
+              <a:alpha val="58000"/>
             </a:srgbClr>
           </a:solidFill>
           <a:ln/>
@@ -3559,7 +3559,7 @@
           </a:prstGeom>
           <a:solidFill>
             <a:srgbClr val="F0F4F8">
-              <a:alpha val="76000"/>
+              <a:alpha val="58000"/>
             </a:srgbClr>
           </a:solidFill>
           <a:ln/>
@@ -3976,7 +3976,7 @@
           </a:prstGeom>
           <a:solidFill>
             <a:srgbClr val="F0F4F8">
-              <a:alpha val="76000"/>
+              <a:alpha val="58000"/>
             </a:srgbClr>
           </a:solidFill>
           <a:ln/>
@@ -4960,7 +4960,7 @@
           </a:prstGeom>
           <a:solidFill>
             <a:srgbClr val="F0F4F8">
-              <a:alpha val="76000"/>
+              <a:alpha val="60000"/>
             </a:srgbClr>
           </a:solidFill>
           <a:ln/>
@@ -6323,7 +6323,7 @@
           </a:prstGeom>
           <a:solidFill>
             <a:srgbClr val="F0F4F8">
-              <a:alpha val="76000"/>
+              <a:alpha val="58000"/>
             </a:srgbClr>
           </a:solidFill>
           <a:ln/>
@@ -7333,7 +7333,7 @@
           </a:prstGeom>
           <a:solidFill>
             <a:srgbClr val="F0F4F8">
-              <a:alpha val="76000"/>
+              <a:alpha val="58000"/>
             </a:srgbClr>
           </a:solidFill>
           <a:ln/>
@@ -7857,7 +7857,7 @@
           </a:prstGeom>
           <a:solidFill>
             <a:srgbClr val="EFF6FF">
-              <a:alpha val="78000"/>
+              <a:alpha val="64000"/>
             </a:srgbClr>
           </a:solidFill>
           <a:ln/>
@@ -8128,7 +8128,7 @@
           </a:prstGeom>
           <a:solidFill>
             <a:srgbClr val="F0F4F8">
-              <a:alpha val="76000"/>
+              <a:alpha val="58000"/>
             </a:srgbClr>
           </a:solidFill>
           <a:ln/>

</xml_diff>